<commit_message>
Update OS 2 Úvod do paralélnych procesov a synchronizácie.pptx
Opravený slide 46 producent konzument obrázok
</commit_message>
<xml_diff>
--- a/OS 2 Úvod do paralélnych procesov a synchronizácie.pptx
+++ b/OS 2 Úvod do paralélnych procesov a synchronizácie.pptx
@@ -191,7 +191,7 @@
   <pc:docChgLst>
     <pc:chgData name="Baráth, Július" userId="aebde9b9-dccc-4475-a9ac-c05e78323d7a" providerId="ADAL" clId="{4A0811C8-ED2F-505E-B787-C8270CED5046}"/>
     <pc:docChg chg="undo custSel addSld delSld modSld sldOrd">
-      <pc:chgData name="Baráth, Július" userId="aebde9b9-dccc-4475-a9ac-c05e78323d7a" providerId="ADAL" clId="{4A0811C8-ED2F-505E-B787-C8270CED5046}" dt="2026-02-03T11:50:35.132" v="568" actId="14100"/>
+      <pc:chgData name="Baráth, Július" userId="aebde9b9-dccc-4475-a9ac-c05e78323d7a" providerId="ADAL" clId="{4A0811C8-ED2F-505E-B787-C8270CED5046}" dt="2026-02-04T09:00:00.349" v="572" actId="1076"/>
       <pc:docMkLst>
         <pc:docMk/>
       </pc:docMkLst>
@@ -275,6 +275,29 @@
             <pc:docMk/>
             <pc:sldMk cId="3347599706" sldId="263"/>
             <ac:spMk id="3" creationId="{00000000-0000-0000-0000-000000000000}"/>
+          </ac:spMkLst>
+        </pc:spChg>
+      </pc:sldChg>
+      <pc:sldChg chg="modSp mod">
+        <pc:chgData name="Baráth, Július" userId="aebde9b9-dccc-4475-a9ac-c05e78323d7a" providerId="ADAL" clId="{4A0811C8-ED2F-505E-B787-C8270CED5046}" dt="2026-02-04T09:00:00.349" v="572" actId="1076"/>
+        <pc:sldMkLst>
+          <pc:docMk/>
+          <pc:sldMk cId="3215213909" sldId="281"/>
+        </pc:sldMkLst>
+        <pc:spChg chg="mod">
+          <ac:chgData name="Baráth, Július" userId="aebde9b9-dccc-4475-a9ac-c05e78323d7a" providerId="ADAL" clId="{4A0811C8-ED2F-505E-B787-C8270CED5046}" dt="2026-02-04T09:00:00.349" v="572" actId="1076"/>
+          <ac:spMkLst>
+            <pc:docMk/>
+            <pc:sldMk cId="3215213909" sldId="281"/>
+            <ac:spMk id="7" creationId="{90D99940-9123-4581-D9AC-BBE8F9D94D6C}"/>
+          </ac:spMkLst>
+        </pc:spChg>
+        <pc:spChg chg="mod">
+          <ac:chgData name="Baráth, Július" userId="aebde9b9-dccc-4475-a9ac-c05e78323d7a" providerId="ADAL" clId="{4A0811C8-ED2F-505E-B787-C8270CED5046}" dt="2026-02-04T08:59:57.082" v="571" actId="1076"/>
+          <ac:spMkLst>
+            <pc:docMk/>
+            <pc:sldMk cId="3215213909" sldId="281"/>
+            <ac:spMk id="8" creationId="{9C641B73-9397-2D5D-2C98-501BC496826F}"/>
           </ac:spMkLst>
         </pc:spChg>
       </pc:sldChg>
@@ -841,7 +864,7 @@
           <a:p>
             <a:fld id="{10DBA715-3931-4B12-8F65-0C023D0C889C}" type="datetimeFigureOut">
               <a:rPr lang="sk-SK" smtClean="0"/>
-              <a:t>3.2.2026</a:t>
+              <a:t>4.2.2026</a:t>
             </a:fld>
             <a:endParaRPr lang="sk-SK"/>
           </a:p>
@@ -1408,7 +1431,7 @@
           <a:p>
             <a:fld id="{FF409D81-0DDF-48BB-84A1-72E2E7B64FA8}" type="datetime1">
               <a:rPr lang="sk-SK" smtClean="0"/>
-              <a:t>3.2.2026</a:t>
+              <a:t>4.2.2026</a:t>
             </a:fld>
             <a:endParaRPr lang="sk-SK"/>
           </a:p>
@@ -1581,7 +1604,7 @@
           <a:p>
             <a:fld id="{A8BDDA65-704B-4A2E-88E9-9C89A9C7184F}" type="datetime1">
               <a:rPr lang="sk-SK" smtClean="0"/>
-              <a:t>3.2.2026</a:t>
+              <a:t>4.2.2026</a:t>
             </a:fld>
             <a:endParaRPr lang="sk-SK"/>
           </a:p>
@@ -1764,7 +1787,7 @@
           <a:p>
             <a:fld id="{C293AB0A-F26A-41CF-9202-51D7B560101E}" type="datetime1">
               <a:rPr lang="sk-SK" smtClean="0"/>
-              <a:t>3.2.2026</a:t>
+              <a:t>4.2.2026</a:t>
             </a:fld>
             <a:endParaRPr lang="sk-SK"/>
           </a:p>
@@ -2010,7 +2033,7 @@
             </a:pPr>
             <a:fld id="{D48FA258-C71C-40CD-814F-D5C504290866}" type="datetime1">
               <a:rPr lang="sk-SK" smtClean="0"/>
-              <a:t>3.2.2026</a:t>
+              <a:t>4.2.2026</a:t>
             </a:fld>
             <a:endParaRPr lang="sk-SK"/>
           </a:p>
@@ -2199,7 +2222,7 @@
           <a:p>
             <a:fld id="{E82BEFB5-8A8B-4407-8C61-8AE7B8D57719}" type="datetime1">
               <a:rPr lang="sk-SK" smtClean="0"/>
-              <a:t>3.2.2026</a:t>
+              <a:t>4.2.2026</a:t>
             </a:fld>
             <a:endParaRPr lang="sk-SK"/>
           </a:p>
@@ -2448,7 +2471,7 @@
           <a:p>
             <a:fld id="{502AAF14-A1CA-4E65-96DD-CCF66B07C433}" type="datetime1">
               <a:rPr lang="sk-SK" smtClean="0"/>
-              <a:t>3.2.2026</a:t>
+              <a:t>4.2.2026</a:t>
             </a:fld>
             <a:endParaRPr lang="sk-SK"/>
           </a:p>
@@ -2683,7 +2706,7 @@
           <a:p>
             <a:fld id="{8087A5FB-5486-48D2-95B9-9A8F76F73722}" type="datetime1">
               <a:rPr lang="sk-SK" smtClean="0"/>
-              <a:t>3.2.2026</a:t>
+              <a:t>4.2.2026</a:t>
             </a:fld>
             <a:endParaRPr lang="sk-SK"/>
           </a:p>
@@ -3053,7 +3076,7 @@
           <a:p>
             <a:fld id="{21BA8A66-795C-44EE-A6A1-16E491829098}" type="datetime1">
               <a:rPr lang="sk-SK" smtClean="0"/>
-              <a:t>3.2.2026</a:t>
+              <a:t>4.2.2026</a:t>
             </a:fld>
             <a:endParaRPr lang="sk-SK"/>
           </a:p>
@@ -3174,7 +3197,7 @@
           <a:p>
             <a:fld id="{3EF3BB14-32E4-4EBF-9407-66EF6DDF6C93}" type="datetime1">
               <a:rPr lang="sk-SK" smtClean="0"/>
-              <a:t>3.2.2026</a:t>
+              <a:t>4.2.2026</a:t>
             </a:fld>
             <a:endParaRPr lang="sk-SK"/>
           </a:p>
@@ -3272,7 +3295,7 @@
           <a:p>
             <a:fld id="{23DE504A-4A64-4A13-A20E-40EF1EDAF191}" type="datetime1">
               <a:rPr lang="sk-SK" smtClean="0"/>
-              <a:t>3.2.2026</a:t>
+              <a:t>4.2.2026</a:t>
             </a:fld>
             <a:endParaRPr lang="sk-SK"/>
           </a:p>
@@ -3552,7 +3575,7 @@
           <a:p>
             <a:fld id="{C5A1DF2D-F2EE-4C69-944D-FEF6D561633F}" type="datetime1">
               <a:rPr lang="sk-SK" smtClean="0"/>
-              <a:t>3.2.2026</a:t>
+              <a:t>4.2.2026</a:t>
             </a:fld>
             <a:endParaRPr lang="sk-SK"/>
           </a:p>
@@ -3808,7 +3831,7 @@
           <a:p>
             <a:fld id="{95D7758C-FDA2-483D-87E1-B45F5DFBD3FD}" type="datetime1">
               <a:rPr lang="sk-SK" smtClean="0"/>
-              <a:t>3.2.2026</a:t>
+              <a:t>4.2.2026</a:t>
             </a:fld>
             <a:endParaRPr lang="sk-SK"/>
           </a:p>
@@ -4024,7 +4047,7 @@
           <a:p>
             <a:fld id="{2605D2B5-92B7-4C8D-AC3A-18C18C239EE2}" type="datetime1">
               <a:rPr lang="sk-SK" smtClean="0"/>
-              <a:t>3.2.2026</a:t>
+              <a:t>4.2.2026</a:t>
             </a:fld>
             <a:endParaRPr lang="sk-SK"/>
           </a:p>
@@ -20272,7 +20295,7 @@
           </p:nvSpPr>
           <p:spPr>
             <a:xfrm>
-              <a:off x="4681169" y="3403850"/>
+              <a:off x="6262688" y="3332074"/>
               <a:ext cx="1144865" cy="369332"/>
             </a:xfrm>
             <a:prstGeom prst="rect">
@@ -20309,7 +20332,7 @@
           </p:nvSpPr>
           <p:spPr>
             <a:xfrm>
-              <a:off x="6184428" y="3403850"/>
+              <a:off x="4567645" y="3332074"/>
               <a:ext cx="1254959" cy="369332"/>
             </a:xfrm>
             <a:prstGeom prst="rect">

</xml_diff>